<commit_message>
fix: boot ROM retries CMD0; sd_prep can write the boot image
The boot ROM sent CMD0 once, so a freshly powered card answering with a
junk byte (0x3f) failed the boot. Retry up to 10 times. The linker region
is now the full 0x2000 boot ROM (Configs.scala), the code no longer fits
in 0x800. Tested on the new bitstream: 5/5 SD boots after card reinsert
and reset.

sd_prep -DSD_PREP_BOOT writes build/boot.bin to LBA 2048 from the board.
Slides: tutorial wording (no report-style history, no 32 KiB analysis),
boot procedure and new resource/timing numbers; PDFs re-exported.
</commit_message>
<xml_diff>
--- a/fpga/sw/export/docs/slides/02_Software_environment_and_tests.pptx
+++ b/fpga/sw/export/docs/slides/02_Software_environment_and_tests.pptx
@@ -8972,7 +8972,7 @@
                           </a:solidFill>
                           <a:latin typeface="Times New Roman"/>
                         </a:rPr>
-                        <a:t>SHA-256/384, HMAC/HKDF, AES-CCM/GCM, KMAC — our own, small</a:t>
+                        <a:t>SHA-256/384, HMAC/HKDF, AES-CCM/GCM, KMAC — written for this tree, small</a:t>
                       </a:r>
                     </a:p>
                   </a:txBody>
@@ -10347,7 +10347,7 @@
                           </a:solidFill>
                           <a:latin typeface="Times New Roman"/>
                         </a:rPr>
-                        <a:t>fits</a:t>
+                        <a:t>left of 64 KiB</a:t>
                       </a:r>
                     </a:p>
                   </a:txBody>
@@ -10503,7 +10503,7 @@
                           </a:solidFill>
                           <a:latin typeface="Times New Roman"/>
                         </a:rPr>
-                        <a:t>32 KiB (229 B left)</a:t>
+                        <a:t>32,997 B</a:t>
                       </a:r>
                     </a:p>
                   </a:txBody>
@@ -10659,7 +10659,7 @@
                           </a:solidFill>
                           <a:latin typeface="Times New Roman"/>
                         </a:rPr>
-                        <a:t>64 KiB only</a:t>
+                        <a:t>4,783 B</a:t>
                       </a:r>
                     </a:p>
                   </a:txBody>
@@ -10842,7 +10842,7 @@
                 </a:solidFill>
                 <a:latin typeface="Times New Roman"/>
               </a:rPr>
-              <a:t>Bigger curves and signatures cost both code and stack: that is why suite and method decide whether 32 KiB is enough (Lesson 1).</a:t>
+              <a:t>Bigger curves and signatures cost both code and stack: suite and method decide how much of the 64 KiB is left.</a:t>
             </a:r>
           </a:p>
         </p:txBody>
@@ -15927,7 +15927,7 @@
                           </a:solidFill>
                           <a:latin typeface="Times New Roman"/>
                         </a:rPr>
-                        <a:t>no C library, our own crt0.S</a:t>
+                        <a:t>no C library, the tree's own crt0.S</a:t>
                       </a:r>
                     </a:p>
                   </a:txBody>
@@ -16109,18 +16109,18 @@
               </a:buClr>
             </a:pPr>
             <a:r>
-              <a:rPr lang="en-US" sz="3500" b="1" spc="-1" dirty="0">
+              <a:rPr lang="en-US" sz="2400" b="1" spc="-1" dirty="0">
                 <a:latin typeface="Times New Roman" panose="02020603050405020304" pitchFamily="18" charset="0"/>
                 <a:cs typeface="Times New Roman" panose="02020603050405020304" pitchFamily="18" charset="0"/>
               </a:rPr>
               <a:t>3. Build System </a:t>
             </a:r>
             <a:r>
-              <a:rPr lang="en-US" sz="3500" spc="-1" dirty="0">
+              <a:rPr lang="en-US" sz="2400" spc="-1" dirty="0">
                 <a:latin typeface="Times New Roman" panose="02020603050405020304" pitchFamily="18" charset="0"/>
                 <a:cs typeface="Times New Roman" panose="02020603050405020304" pitchFamily="18" charset="0"/>
               </a:rPr>
-              <a:t>(3/4) A real build bug: stale objects</a:t>
+              <a:t>(3/4) Switching suite, method or role: no make clean needed</a:t>
             </a:r>
           </a:p>
         </p:txBody>
@@ -16236,7 +16236,7 @@
                 </a:solidFill>
                 <a:latin typeface="Times New Roman"/>
               </a:rPr>
-              <a:t> folder and differ only in flags (method, role, suite).</a:t>
+              <a:t> folder and differ only in flags (method, role, suite). Make by itself compares only file times, so it would reuse objects built with other flags — an image of the wrong method, no error.</a:t>
             </a:r>
           </a:p>
           <a:p>
@@ -16253,61 +16253,7 @@
                 </a:solidFill>
                 <a:latin typeface="Times New Roman"/>
               </a:rPr>
-              <a:t>Make only looks at file times. Building </a:t>
-            </a:r>
-            <a:r>
-              <a:rPr sz="1700" b="0" i="1">
-                <a:solidFill>
-                  <a:srgbClr val="000000"/>
-                </a:solidFill>
-                <a:latin typeface="Times New Roman"/>
-              </a:rPr>
-              <a:t>m1_responder</a:t>
-            </a:r>
-            <a:r>
-              <a:rPr sz="1700" b="0">
-                <a:solidFill>
-                  <a:srgbClr val="000000"/>
-                </a:solidFill>
-                <a:latin typeface="Times New Roman"/>
-              </a:rPr>
-              <a:t> and then </a:t>
-            </a:r>
-            <a:r>
-              <a:rPr sz="1700" b="0" i="1">
-                <a:solidFill>
-                  <a:srgbClr val="000000"/>
-                </a:solidFill>
-                <a:latin typeface="Times New Roman"/>
-              </a:rPr>
-              <a:t>m2_initiator</a:t>
-            </a:r>
-            <a:r>
-              <a:rPr sz="1700" b="0">
-                <a:solidFill>
-                  <a:srgbClr val="000000"/>
-                </a:solidFill>
-                <a:latin typeface="Times New Roman"/>
-              </a:rPr>
-              <a:t> reused objects compiled for method 1 → </a:t>
-            </a:r>
-            <a:r>
-              <a:rPr sz="1700" b="1">
-                <a:solidFill>
-                  <a:srgbClr val="000000"/>
-                </a:solidFill>
-                <a:latin typeface="Times New Roman"/>
-              </a:rPr>
-              <a:t>an image of the wrong method</a:t>
-            </a:r>
-            <a:r>
-              <a:rPr sz="1700" b="0">
-                <a:solidFill>
-                  <a:srgbClr val="000000"/>
-                </a:solidFill>
-                <a:latin typeface="Times New Roman"/>
-              </a:rPr>
-              <a:t>, no error, wrong handshake.</a:t>
+              <a:t>The build keeps an empty stamp file named after a hash of the flags. New flags → new stamp name → every object is older than its stamp → everything recompiles.</a:t>
             </a:r>
           </a:p>
           <a:p>
@@ -16324,16 +16270,17 @@
                 </a:solidFill>
                 <a:latin typeface="Times New Roman"/>
               </a:rPr>
-              <a:t>Fix: an empty stamp file named after a hash of the flags. New flags → new stamp name → every object is older than its stamp → rebuild.</a:t>
-            </a:r>
-          </a:p>
-          <a:p>
-            <a:pPr marL="256032" indent="-219456">
-              <a:spcAft>
-                <a:spcPts val="400"/>
-              </a:spcAft>
-              <a:buChar char="•"/>
-            </a:pPr>
+              <a:t>Check it: run </a:t>
+            </a:r>
+            <a:r>
+              <a:rPr sz="1500" b="0">
+                <a:solidFill>
+                  <a:srgbClr val="8B1A1A"/>
+                </a:solidFill>
+                <a:latin typeface="Consolas"/>
+              </a:rPr>
+              <a:t>ls build/.cflags-*</a:t>
+            </a:r>
             <a:r>
               <a:rPr sz="1700" b="0">
                 <a:solidFill>
@@ -16341,25 +16288,7 @@
                 </a:solidFill>
                 <a:latin typeface="Times New Roman"/>
               </a:rPr>
-              <a:t>Check it: </a:t>
-            </a:r>
-            <a:r>
-              <a:rPr sz="1500" b="0">
-                <a:solidFill>
-                  <a:srgbClr val="8B1A1A"/>
-                </a:solidFill>
-                <a:latin typeface="Consolas"/>
-              </a:rPr>
-              <a:t>ls build/.cflags-*</a:t>
-            </a:r>
-            <a:r>
-              <a:rPr sz="1700" b="0">
-                <a:solidFill>
-                  <a:srgbClr val="000000"/>
-                </a:solidFill>
-                <a:latin typeface="Times New Roman"/>
-              </a:rPr>
-              <a:t> before and after changing CRYPTO_SUITE — the name changes and every object compiles again.</a:t>
+              <a:t>, build with another CRYPTO_SUITE, run it again — the name changes and every object compiles again.</a:t>
             </a:r>
           </a:p>
         </p:txBody>
@@ -22348,18 +22277,18 @@
               </a:buClr>
             </a:pPr>
             <a:r>
-              <a:rPr lang="en-US" sz="3600" b="1" spc="-1" dirty="0">
+              <a:rPr lang="en-US" sz="3200" b="1" spc="-1" dirty="0">
                 <a:latin typeface="Times New Roman" panose="02020603050405020304" pitchFamily="18" charset="0"/>
                 <a:cs typeface="Times New Roman" panose="02020603050405020304" pitchFamily="18" charset="0"/>
               </a:rPr>
               <a:t>5. Peripheral Tests </a:t>
             </a:r>
             <a:r>
-              <a:rPr lang="en-US" sz="3600" spc="-1" dirty="0">
+              <a:rPr lang="en-US" sz="3200" spc="-1" dirty="0">
                 <a:latin typeface="Times New Roman" panose="02020603050405020304" pitchFamily="18" charset="0"/>
                 <a:cs typeface="Times New Roman" panose="02020603050405020304" pitchFamily="18" charset="0"/>
               </a:rPr>
-              <a:t>(3/3) What the SD test taught us</a:t>
+              <a:t>(3/3) If spi_test shows R1 = 3f or 7f</a:t>
             </a:r>
           </a:p>
         </p:txBody>
@@ -22560,25 +22489,7 @@
                 </a:solidFill>
                 <a:latin typeface="Times New Roman"/>
               </a:rPr>
-              <a:t>The first version reported SD </a:t>
-            </a:r>
-            <a:r>
-              <a:rPr sz="1800" b="1">
-                <a:solidFill>
-                  <a:srgbClr val="000000"/>
-                </a:solidFill>
-                <a:latin typeface="Times New Roman"/>
-              </a:rPr>
-              <a:t>FAIL</a:t>
-            </a:r>
-            <a:r>
-              <a:rPr sz="1800" b="0">
-                <a:solidFill>
-                  <a:srgbClr val="000000"/>
-                </a:solidFill>
-                <a:latin typeface="Times New Roman"/>
-              </a:rPr>
-              <a:t> on both boards (R1 = 0x3f / 0x7f). The cards were fine.</a:t>
+              <a:t>Right after the card powers up it can answer the first CMD0 with one junk byte (bit 7 clear, e.g. 0x3f). The card is fine.</a:t>
             </a:r>
           </a:p>
           <a:p>
@@ -22595,7 +22506,7 @@
                 </a:solidFill>
                 <a:latin typeface="Times New Roman"/>
               </a:rPr>
-              <a:t>Right after power-up the card sends one junk byte with bit 7 clear before its real answer; the test took the junk for the answer.</a:t>
+              <a:t>spi_test, the firmware and the boot ROM all send CMD0 up to 10 times until R1 = 0x01, so normally you only see PASS.</a:t>
             </a:r>
           </a:p>
           <a:p>
@@ -22612,7 +22523,7 @@
                 </a:solidFill>
                 <a:latin typeface="Times New Roman"/>
               </a:rPr>
-              <a:t>Fix: send CMD0 up to 10 times until R1 = 0x01 (tests and firmware). Most SD drivers do the same.</a:t>
+              <a:t>If you still see 3f / 7f: check the card is pushed fully in and the PmodMicroSD sits in the top row of JA; then print the raw bytes (as above) — not every card answers at the same moment.</a:t>
             </a:r>
           </a:p>
           <a:p>
@@ -22629,7 +22540,7 @@
                 </a:solidFill>
                 <a:latin typeface="Times New Roman"/>
               </a:rPr>
-              <a:t>Lesson: print the </a:t>
+              <a:t>Rule of thumb for any SPI device: look at the </a:t>
             </a:r>
             <a:r>
               <a:rPr sz="1800" b="1">

</xml_diff>

<commit_message>
docs: no-conda setup, tested on a clean Ubuntu 24.04
Install only what the course uses: apt packages (incl. jq, JDK 17, dtc),
riscv-gnu-toolchain 2025.06.07 from source (with the moved newlib/binutils
mirrors), the Chipyard submodule script and firtool 1.61.0. No Verilator,
FireSim or FireMarshal. New Lesson 1 slides for Vivado, the tools and
route A; the closure recipe is split in two Vivado runs so a crash after
routing only repeats the short part.
</commit_message>
<xml_diff>
--- a/fpga/sw/export/docs/slides/02_Software_environment_and_tests.pptx
+++ b/fpga/sw/export/docs/slides/02_Software_environment_and_tests.pptx
@@ -7616,7 +7616,7 @@
         <p:spPr>
           <a:xfrm>
             <a:off x="365760" y="868680"/>
-            <a:ext cx="11430000" cy="1595628"/>
+            <a:ext cx="11430000" cy="2215388"/>
           </a:xfrm>
           <a:prstGeom prst="rect">
             <a:avLst/>
@@ -7649,13 +7649,25 @@
           <a:bodyPr rtlCol="0" anchor="t" wrap="none" lIns="73152" rIns="73152" tIns="73152" bIns="73152"/>
           <a:lstStyle/>
           <a:p>
+            <a:pPr algn="l"/>
+            <a:r>
+              <a:rPr sz="1300" b="1">
+                <a:solidFill>
+                  <a:srgbClr val="808080"/>
+                </a:solidFill>
+                <a:latin typeface="Consolas"/>
+              </a:rPr>
+              <a:t>Run this — already done if you followed Lesson 1, (7/11)</a:t>
+            </a:r>
+          </a:p>
+          <a:p>
             <a:pPr algn="l">
               <a:lnSpc>
                 <a:spcPct val="100000"/>
               </a:lnSpc>
             </a:pPr>
             <a:r>
-              <a:rPr sz="1500">
+              <a:rPr sz="1300">
                 <a:solidFill>
                   <a:srgbClr val="1F1F1F"/>
                 </a:solidFill>
@@ -7671,13 +7683,13 @@
               </a:lnSpc>
             </a:pPr>
             <a:r>
-              <a:rPr sz="1500">
+              <a:rPr sz="1300">
                 <a:solidFill>
                   <a:srgbClr val="1F1F1F"/>
                 </a:solidFill>
                 <a:latin typeface="Consolas"/>
               </a:rPr>
-              <a:t>cd riscv-gnu-toolchain</a:t>
+              <a:t>cd riscv-gnu-toolchain &amp;&amp; git checkout 2025.06.07</a:t>
             </a:r>
           </a:p>
           <a:p>
@@ -7687,13 +7699,13 @@
               </a:lnSpc>
             </a:pPr>
             <a:r>
-              <a:rPr sz="1500">
+              <a:rPr sz="1300">
                 <a:solidFill>
                   <a:srgbClr val="1F1F1F"/>
                 </a:solidFill>
                 <a:latin typeface="Consolas"/>
               </a:rPr>
-              <a:t>./configure --prefix=$HOME/opt/riscv --with-multilib-generator="rv64imac-lp64--"</a:t>
+              <a:t>git config submodule.binutils.url https://github.com/gnutools/binutils-gdb.git</a:t>
             </a:r>
           </a:p>
           <a:p>
@@ -7703,13 +7715,13 @@
               </a:lnSpc>
             </a:pPr>
             <a:r>
-              <a:rPr sz="1500">
+              <a:rPr sz="1300">
                 <a:solidFill>
                   <a:srgbClr val="1F1F1F"/>
                 </a:solidFill>
                 <a:latin typeface="Consolas"/>
               </a:rPr>
-              <a:t>make -j$(nproc)                        # newlib (bare-metal) toolchain</a:t>
+              <a:t>git config submodule.gdb.url https://github.com/gnutools/binutils-gdb.git</a:t>
             </a:r>
           </a:p>
           <a:p>
@@ -7719,13 +7731,13 @@
               </a:lnSpc>
             </a:pPr>
             <a:r>
-              <a:rPr sz="1500">
+              <a:rPr sz="1300">
                 <a:solidFill>
                   <a:srgbClr val="1F1F1F"/>
                 </a:solidFill>
                 <a:latin typeface="Consolas"/>
               </a:rPr>
-              <a:t>export PATH=$HOME/opt/riscv/bin:$PATH</a:t>
+              <a:t>git config submodule.newlib.url https://github.com/cygwin/cygwin.git</a:t>
             </a:r>
           </a:p>
           <a:p>
@@ -7735,13 +7747,61 @@
               </a:lnSpc>
             </a:pPr>
             <a:r>
-              <a:rPr sz="1500">
+              <a:rPr sz="1300">
                 <a:solidFill>
                   <a:srgbClr val="1F1F1F"/>
                 </a:solidFill>
                 <a:latin typeface="Consolas"/>
               </a:rPr>
-              <a:t>riscv64-unknown-elf-gcc --version      # ours: 15.1.0</a:t>
+              <a:t>./configure --prefix=$HOME/opt/riscv --with-multilib-generator="rv64imac-lp64--"</a:t>
+            </a:r>
+          </a:p>
+          <a:p>
+            <a:pPr algn="l">
+              <a:lnSpc>
+                <a:spcPct val="100000"/>
+              </a:lnSpc>
+            </a:pPr>
+            <a:r>
+              <a:rPr sz="1300">
+                <a:solidFill>
+                  <a:srgbClr val="1F1F1F"/>
+                </a:solidFill>
+                <a:latin typeface="Consolas"/>
+              </a:rPr>
+              <a:t>make -j$(nproc)                        # newlib (bare-metal) toolchain</a:t>
+            </a:r>
+          </a:p>
+          <a:p>
+            <a:pPr algn="l">
+              <a:lnSpc>
+                <a:spcPct val="100000"/>
+              </a:lnSpc>
+            </a:pPr>
+            <a:r>
+              <a:rPr sz="1300">
+                <a:solidFill>
+                  <a:srgbClr val="1F1F1F"/>
+                </a:solidFill>
+                <a:latin typeface="Consolas"/>
+              </a:rPr>
+              <a:t>export PATH=$HOME/opt/riscv/bin:$PATH</a:t>
+            </a:r>
+          </a:p>
+          <a:p>
+            <a:pPr algn="l">
+              <a:lnSpc>
+                <a:spcPct val="100000"/>
+              </a:lnSpc>
+            </a:pPr>
+            <a:r>
+              <a:rPr sz="1300">
+                <a:solidFill>
+                  <a:srgbClr val="1F1F1F"/>
+                </a:solidFill>
+                <a:latin typeface="Consolas"/>
+              </a:rPr>
+              <a:t>riscv64-unknown-elf-gcc --version      # 15.1.0</a:t>
             </a:r>
           </a:p>
         </p:txBody>
@@ -7754,7 +7814,7 @@
         </p:nvSpPr>
         <p:spPr>
           <a:xfrm>
-            <a:off x="365760" y="2738627"/>
+            <a:off x="365760" y="3358388"/>
             <a:ext cx="11430000" cy="2926080"/>
           </a:xfrm>
           <a:prstGeom prst="rect">
@@ -7775,7 +7835,7 @@
               <a:buChar char="•"/>
             </a:pPr>
             <a:r>
-              <a:rPr sz="1800" b="0">
+              <a:rPr sz="1600" b="0">
                 <a:solidFill>
                   <a:srgbClr val="000000"/>
                 </a:solidFill>
@@ -7784,7 +7844,7 @@
               <a:t>Bare metal: no operating system, no C library at run time — the firmware brings its own </a:t>
             </a:r>
             <a:r>
-              <a:rPr sz="1800" b="0" i="1">
+              <a:rPr sz="1600" b="0" i="1">
                 <a:solidFill>
                   <a:srgbClr val="000000"/>
                 </a:solidFill>
@@ -7793,7 +7853,7 @@
               <a:t>memcpy</a:t>
             </a:r>
             <a:r>
-              <a:rPr sz="1800" b="0">
+              <a:rPr sz="1600" b="0">
                 <a:solidFill>
                   <a:srgbClr val="000000"/>
                 </a:solidFill>
@@ -7802,7 +7862,7 @@
               <a:t>, </a:t>
             </a:r>
             <a:r>
-              <a:rPr sz="1800" b="0" i="1">
+              <a:rPr sz="1600" b="0" i="1">
                 <a:solidFill>
                   <a:srgbClr val="000000"/>
                 </a:solidFill>
@@ -7811,7 +7871,7 @@
               <a:t>printf</a:t>
             </a:r>
             <a:r>
-              <a:rPr sz="1800" b="0">
+              <a:rPr sz="1600" b="0">
                 <a:solidFill>
                   <a:srgbClr val="000000"/>
                 </a:solidFill>
@@ -7828,7 +7888,7 @@
               <a:buChar char="•"/>
             </a:pPr>
             <a:r>
-              <a:rPr sz="1800" b="0">
+              <a:rPr sz="1600" b="0">
                 <a:solidFill>
                   <a:srgbClr val="000000"/>
                 </a:solidFill>
@@ -7837,7 +7897,7 @@
               <a:t>Target: </a:t>
             </a:r>
             <a:r>
-              <a:rPr sz="1800" b="1">
+              <a:rPr sz="1600" b="1">
                 <a:solidFill>
                   <a:srgbClr val="000000"/>
                 </a:solidFill>
@@ -7846,7 +7906,7 @@
               <a:t>rv64imac / lp64</a:t>
             </a:r>
             <a:r>
-              <a:rPr sz="1800" b="0">
+              <a:rPr sz="1600" b="0">
                 <a:solidFill>
                   <a:srgbClr val="000000"/>
                 </a:solidFill>
@@ -7863,7 +7923,7 @@
               <a:buChar char="•"/>
             </a:pPr>
             <a:r>
-              <a:rPr sz="1800" b="0">
+              <a:rPr sz="1600" b="0">
                 <a:solidFill>
                   <a:srgbClr val="000000"/>
                 </a:solidFill>
@@ -7872,7 +7932,7 @@
               <a:t>Toolchain somewhere else? Pass the prefix instead of PATH: </a:t>
             </a:r>
             <a:r>
-              <a:rPr sz="1600" b="0">
+              <a:rPr sz="1400" b="0">
                 <a:solidFill>
                   <a:srgbClr val="8B1A1A"/>
                 </a:solidFill>
@@ -7889,7 +7949,7 @@
               <a:buChar char="•"/>
             </a:pPr>
             <a:r>
-              <a:rPr sz="1800" b="0">
+              <a:rPr sz="1600" b="0">
                 <a:solidFill>
                   <a:srgbClr val="000000"/>
                 </a:solidFill>

</xml_diff>

<commit_message>
docs: paste-safe setup: $REPO in every block, settings in ~/.bashrc
Every Run this block starts with cd $REPO/...; REPO, PATH, RISCV, firtool
and Vivado settings go into ~/.bashrc so any new terminal works. Install
order fixed for a bare Ubuntu (packages before git clone); the Python venv
is pinned and activated where Python runs; the readiness check prints
MISSING for absent tools; dialout/plugdev group command added.

Tested by pasting the README blocks in order in a clean Ubuntu 24.04
container: all exit 0, no MISSING; Lesson 4 reference model and Lesson 5
FAT32 test PASS.
</commit_message>
<xml_diff>
--- a/fpga/sw/export/docs/slides/02_Software_environment_and_tests.pptx
+++ b/fpga/sw/export/docs/slides/02_Software_environment_and_tests.pptx
@@ -7616,7 +7616,7 @@
         <p:spPr>
           <a:xfrm>
             <a:off x="365760" y="868680"/>
-            <a:ext cx="11430000" cy="2215388"/>
+            <a:ext cx="11430000" cy="2416810"/>
           </a:xfrm>
           <a:prstGeom prst="rect">
             <a:avLst/>
@@ -7657,7 +7657,23 @@
                 </a:solidFill>
                 <a:latin typeface="Consolas"/>
               </a:rPr>
-              <a:t>Run this — already done if you followed Lesson 1, (7/11)</a:t>
+              <a:t>Run this — already done if you followed Lesson 1, (7/12)</a:t>
+            </a:r>
+          </a:p>
+          <a:p>
+            <a:pPr algn="l">
+              <a:lnSpc>
+                <a:spcPct val="100000"/>
+              </a:lnSpc>
+            </a:pPr>
+            <a:r>
+              <a:rPr sz="1300">
+                <a:solidFill>
+                  <a:srgbClr val="1F1F1F"/>
+                </a:solidFill>
+                <a:latin typeface="Consolas"/>
+              </a:rPr>
+              <a:t>cd ~</a:t>
             </a:r>
           </a:p>
           <a:p>
@@ -7814,7 +7830,7 @@
         </p:nvSpPr>
         <p:spPr>
           <a:xfrm>
-            <a:off x="365760" y="3358388"/>
+            <a:off x="365760" y="3559809"/>
             <a:ext cx="11430000" cy="2926080"/>
           </a:xfrm>
           <a:prstGeom prst="rect">
@@ -10079,7 +10095,7 @@
                 </a:solidFill>
                 <a:latin typeface="Consolas"/>
               </a:rPr>
-              <a:t>cd fpga/sw/export/edhoc-wolfssl</a:t>
+              <a:t>cd $REPO/fpga/sw/export/edhoc-wolfssl</a:t>
             </a:r>
           </a:p>
           <a:p>
@@ -12145,7 +12161,7 @@
                 </a:solidFill>
                 <a:latin typeface="Consolas"/>
               </a:rPr>
-              <a:t>cd fpga/sw/export</a:t>
+              <a:t>cd $REPO/fpga/sw/export</a:t>
             </a:r>
           </a:p>
           <a:p>
@@ -12944,7 +12960,7 @@
                 </a:solidFill>
                 <a:latin typeface="Consolas"/>
               </a:rPr>
-              <a:t>Edit — fpga/sw/export/common/board/boards.env (ships with ours: replace all four)</a:t>
+              <a:t>Edit — $REPO/fpga/sw/export/common/board/boards.env (ships with ours: replace all four)</a:t>
             </a:r>
           </a:p>
           <a:p>
@@ -13079,7 +13095,7 @@
                 </a:solidFill>
                 <a:latin typeface="Consolas"/>
               </a:rPr>
-              <a:t>cd fpga/sw/export/tests &amp;&amp; make gpio_test</a:t>
+              <a:t>cd $REPO/fpga/sw/export/tests &amp;&amp; make gpio_test</a:t>
             </a:r>
           </a:p>
           <a:p>
@@ -13751,7 +13767,7 @@
                 </a:solidFill>
                 <a:latin typeface="Consolas"/>
               </a:rPr>
-              <a:t>cd fpga/sw/export/tests</a:t>
+              <a:t>cd $REPO/fpga/sw/export/tests</a:t>
             </a:r>
           </a:p>
           <a:p>
@@ -15260,7 +15276,7 @@
                 </a:solidFill>
                 <a:latin typeface="Consolas"/>
               </a:rPr>
-              <a:t>cd fpga/sw/export/edhoc-wolfssl</a:t>
+              <a:t>cd $REPO/fpga/sw/export/edhoc-wolfssl</a:t>
             </a:r>
           </a:p>
           <a:p>
@@ -21684,7 +21700,7 @@
                 </a:solidFill>
                 <a:latin typeface="Consolas"/>
               </a:rPr>
-              <a:t>cd fpga/sw/export/tests</a:t>
+              <a:t>cd $REPO/fpga/sw/export/tests</a:t>
             </a:r>
           </a:p>
           <a:p>

</xml_diff>